<commit_message>
docs: add speaker notes to all 10 PowerPoint slides
Each slide now includes detailed speaker notes covering:
- Slide 1: Welcome and project overview
- Slide 2: Agenda walkthrough
- Slide 3: Legacy COBOL system details and PIC 9(6)V99 format
- Slide 4: Five modernization strategy principles
- Slide 5: COBOL-to-Node.js construct mapping explanations
- Slide 6: Debit operation code walkthrough and testability improvement
- Slide 7: Test suite coverage and floating-point precision verification
- Slide 8: Seven-stage deployment pipeline details
- Slide 9: Technical decision rationale (readline-sync, Math.round, etc.)
- Slide 10: Results summary and future roadmap

Co-Authored-By: Devin AI <158243242+devin-ai-integration[bot]@users.noreply.github.com>
</commit_message>
<xml_diff>
--- a/node-app/docs/COBOL_to_NodeJS_Migration.pptx
+++ b/node-app/docs/COBOL_to_NodeJS_Migration.pptx
@@ -6,15 +6,15 @@
   </p:sldMasterIdLst>
   <p:sldIdLst>
     <p:sldId id="256" r:id="rId7"/>
-    <p:sldId id="257" r:id="rId8"/>
-    <p:sldId id="258" r:id="rId9"/>
-    <p:sldId id="259" r:id="rId10"/>
-    <p:sldId id="260" r:id="rId11"/>
-    <p:sldId id="261" r:id="rId12"/>
-    <p:sldId id="262" r:id="rId13"/>
-    <p:sldId id="263" r:id="rId14"/>
-    <p:sldId id="264" r:id="rId15"/>
-    <p:sldId id="265" r:id="rId16"/>
+    <p:sldId id="257" r:id="rId9"/>
+    <p:sldId id="258" r:id="rId10"/>
+    <p:sldId id="259" r:id="rId11"/>
+    <p:sldId id="260" r:id="rId12"/>
+    <p:sldId id="261" r:id="rId13"/>
+    <p:sldId id="262" r:id="rId14"/>
+    <p:sldId id="263" r:id="rId15"/>
+    <p:sldId id="264" r:id="rId16"/>
+    <p:sldId id="265" r:id="rId17"/>
   </p:sldIdLst>
   <p:sldSz cx="9144000" cy="6858000" type="screen4x3"/>
   <p:notesSz cx="6858000" cy="9144000"/>
@@ -114,6 +114,1278 @@
     </a:lvl9pPr>
   </p:defaultTextStyle>
 </p:presentation>
+</file>
+
+<file path=ppt/notesMasters/notesMaster1.xml><?xml version="1.0" encoding="utf-8"?>
+<p:notesMaster xmlns:a="http://schemas.openxmlformats.org/drawingml/2006/main" xmlns:p="http://schemas.openxmlformats.org/presentationml/2006/main" xmlns:r="http://schemas.openxmlformats.org/officeDocument/2006/relationships">
+  <p:cSld>
+    <p:bg>
+      <p:bgRef idx="1001">
+        <a:schemeClr val="bg1"/>
+      </p:bgRef>
+    </p:bg>
+    <p:spTree>
+      <p:nvGrpSpPr>
+        <p:cNvPr id="1" name=""/>
+        <p:cNvGrpSpPr/>
+        <p:nvPr/>
+      </p:nvGrpSpPr>
+      <p:grpSpPr>
+        <a:xfrm>
+          <a:off x="0" y="0"/>
+          <a:ext cx="0" cy="0"/>
+          <a:chOff x="0" y="0"/>
+          <a:chExt cx="0" cy="0"/>
+        </a:xfrm>
+      </p:grpSpPr>
+      <p:sp>
+        <p:nvSpPr>
+          <p:cNvPr id="2" name="Header Placeholder 1"/>
+          <p:cNvSpPr>
+            <a:spLocks noGrp="1"/>
+          </p:cNvSpPr>
+          <p:nvPr>
+            <p:ph type="hdr" sz="quarter"/>
+          </p:nvPr>
+        </p:nvSpPr>
+        <p:spPr>
+          <a:xfrm>
+            <a:off x="0" y="0"/>
+            <a:ext cx="2971800" cy="457200"/>
+          </a:xfrm>
+          <a:prstGeom prst="rect">
+            <a:avLst/>
+          </a:prstGeom>
+        </p:spPr>
+        <p:txBody>
+          <a:bodyPr vert="horz" lIns="91440" tIns="45720" rIns="91440" bIns="45720" rtlCol="0"/>
+          <a:lstStyle>
+            <a:lvl1pPr algn="l">
+              <a:defRPr sz="1200"/>
+            </a:lvl1pPr>
+          </a:lstStyle>
+          <a:p>
+            <a:endParaRPr lang="en-US"/>
+          </a:p>
+        </p:txBody>
+      </p:sp>
+      <p:sp>
+        <p:nvSpPr>
+          <p:cNvPr id="3" name="Date Placeholder 2"/>
+          <p:cNvSpPr>
+            <a:spLocks noGrp="1"/>
+          </p:cNvSpPr>
+          <p:nvPr>
+            <p:ph type="dt" idx="1"/>
+          </p:nvPr>
+        </p:nvSpPr>
+        <p:spPr>
+          <a:xfrm>
+            <a:off x="3884613" y="0"/>
+            <a:ext cx="2971800" cy="457200"/>
+          </a:xfrm>
+          <a:prstGeom prst="rect">
+            <a:avLst/>
+          </a:prstGeom>
+        </p:spPr>
+        <p:txBody>
+          <a:bodyPr vert="horz" lIns="91440" tIns="45720" rIns="91440" bIns="45720" rtlCol="0"/>
+          <a:lstStyle>
+            <a:lvl1pPr algn="r">
+              <a:defRPr sz="1200"/>
+            </a:lvl1pPr>
+          </a:lstStyle>
+          <a:p>
+            <a:fld id="{0F89C1C7-3DCD-1040-A9CF-14679D8B5DDD}" type="datetimeFigureOut">
+              <a:rPr lang="en-US" smtClean="0"/>
+              <a:t>10/17/16</a:t>
+            </a:fld>
+            <a:endParaRPr lang="en-US"/>
+          </a:p>
+        </p:txBody>
+      </p:sp>
+      <p:sp>
+        <p:nvSpPr>
+          <p:cNvPr id="4" name="Slide Image Placeholder 3"/>
+          <p:cNvSpPr>
+            <a:spLocks noGrp="1" noRot="1" noChangeAspect="1"/>
+          </p:cNvSpPr>
+          <p:nvPr>
+            <p:ph type="sldImg" idx="2"/>
+          </p:nvPr>
+        </p:nvSpPr>
+        <p:spPr>
+          <a:xfrm>
+            <a:off x="1143000" y="685800"/>
+            <a:ext cx="4572000" cy="3429000"/>
+          </a:xfrm>
+          <a:prstGeom prst="rect">
+            <a:avLst/>
+          </a:prstGeom>
+          <a:noFill/>
+          <a:ln w="12700">
+            <a:solidFill>
+              <a:prstClr val="black"/>
+            </a:solidFill>
+          </a:ln>
+        </p:spPr>
+        <p:txBody>
+          <a:bodyPr vert="horz" lIns="91440" tIns="45720" rIns="91440" bIns="45720" rtlCol="0" anchor="ctr"/>
+          <a:lstStyle/>
+          <a:p>
+            <a:endParaRPr lang="en-US"/>
+          </a:p>
+        </p:txBody>
+      </p:sp>
+      <p:sp>
+        <p:nvSpPr>
+          <p:cNvPr id="5" name="Notes Placeholder 4"/>
+          <p:cNvSpPr>
+            <a:spLocks noGrp="1"/>
+          </p:cNvSpPr>
+          <p:nvPr>
+            <p:ph type="body" sz="quarter" idx="3"/>
+          </p:nvPr>
+        </p:nvSpPr>
+        <p:spPr>
+          <a:xfrm>
+            <a:off x="685800" y="4343400"/>
+            <a:ext cx="5486400" cy="4114800"/>
+          </a:xfrm>
+          <a:prstGeom prst="rect">
+            <a:avLst/>
+          </a:prstGeom>
+        </p:spPr>
+        <p:txBody>
+          <a:bodyPr vert="horz" lIns="91440" tIns="45720" rIns="91440" bIns="45720" rtlCol="0"/>
+          <a:lstStyle/>
+          <a:p>
+            <a:pPr lvl="0"/>
+            <a:r>
+              <a:rPr lang="en-US" smtClean="0"/>
+              <a:t>Click to edit Master text styles</a:t>
+            </a:r>
+          </a:p>
+          <a:p>
+            <a:pPr lvl="1"/>
+            <a:r>
+              <a:rPr lang="en-US" smtClean="0"/>
+              <a:t>Second level</a:t>
+            </a:r>
+          </a:p>
+          <a:p>
+            <a:pPr lvl="2"/>
+            <a:r>
+              <a:rPr lang="en-US" smtClean="0"/>
+              <a:t>Third level</a:t>
+            </a:r>
+          </a:p>
+          <a:p>
+            <a:pPr lvl="3"/>
+            <a:r>
+              <a:rPr lang="en-US" smtClean="0"/>
+              <a:t>Fourth level</a:t>
+            </a:r>
+          </a:p>
+          <a:p>
+            <a:pPr lvl="4"/>
+            <a:r>
+              <a:rPr lang="en-US" smtClean="0"/>
+              <a:t>Fifth level</a:t>
+            </a:r>
+            <a:endParaRPr lang="en-US"/>
+          </a:p>
+        </p:txBody>
+      </p:sp>
+      <p:sp>
+        <p:nvSpPr>
+          <p:cNvPr id="6" name="Footer Placeholder 5"/>
+          <p:cNvSpPr>
+            <a:spLocks noGrp="1"/>
+          </p:cNvSpPr>
+          <p:nvPr>
+            <p:ph type="ftr" sz="quarter" idx="4"/>
+          </p:nvPr>
+        </p:nvSpPr>
+        <p:spPr>
+          <a:xfrm>
+            <a:off x="0" y="8685213"/>
+            <a:ext cx="2971800" cy="457200"/>
+          </a:xfrm>
+          <a:prstGeom prst="rect">
+            <a:avLst/>
+          </a:prstGeom>
+        </p:spPr>
+        <p:txBody>
+          <a:bodyPr vert="horz" lIns="91440" tIns="45720" rIns="91440" bIns="45720" rtlCol="0" anchor="b"/>
+          <a:lstStyle>
+            <a:lvl1pPr algn="l">
+              <a:defRPr sz="1200"/>
+            </a:lvl1pPr>
+          </a:lstStyle>
+          <a:p>
+            <a:endParaRPr lang="en-US"/>
+          </a:p>
+        </p:txBody>
+      </p:sp>
+      <p:sp>
+        <p:nvSpPr>
+          <p:cNvPr id="7" name="Slide Number Placeholder 6"/>
+          <p:cNvSpPr>
+            <a:spLocks noGrp="1"/>
+          </p:cNvSpPr>
+          <p:nvPr>
+            <p:ph type="sldNum" sz="quarter" idx="5"/>
+          </p:nvPr>
+        </p:nvSpPr>
+        <p:spPr>
+          <a:xfrm>
+            <a:off x="3884613" y="8685213"/>
+            <a:ext cx="2971800" cy="457200"/>
+          </a:xfrm>
+          <a:prstGeom prst="rect">
+            <a:avLst/>
+          </a:prstGeom>
+        </p:spPr>
+        <p:txBody>
+          <a:bodyPr vert="horz" lIns="91440" tIns="45720" rIns="91440" bIns="45720" rtlCol="0" anchor="b"/>
+          <a:lstStyle>
+            <a:lvl1pPr algn="r">
+              <a:defRPr sz="1200"/>
+            </a:lvl1pPr>
+          </a:lstStyle>
+          <a:p>
+            <a:fld id="{BB5E49A5-4136-284D-997B-48E1D791AD67}" type="slidenum">
+              <a:rPr lang="en-US" smtClean="0"/>
+              <a:t>‹#›</a:t>
+            </a:fld>
+            <a:endParaRPr lang="en-US"/>
+          </a:p>
+        </p:txBody>
+      </p:sp>
+    </p:spTree>
+    <p:extLst>
+      <p:ext uri="{BB962C8B-B14F-4D97-AF65-F5344CB8AC3E}">
+        <p14:creationId xmlns:p14="http://schemas.microsoft.com/office/powerpoint/2010/main" val="2623252185"/>
+      </p:ext>
+    </p:extLst>
+  </p:cSld>
+  <p:clrMap bg1="lt1" tx1="dk1" bg2="lt2" tx2="dk2" accent1="accent1" accent2="accent2" accent3="accent3" accent4="accent4" accent5="accent5" accent6="accent6" hlink="hlink" folHlink="folHlink"/>
+  <p:notesStyle>
+    <a:lvl1pPr marL="0" algn="l" defTabSz="457200" rtl="0" eaLnBrk="1" latinLnBrk="0" hangingPunct="1">
+      <a:defRPr sz="1200" kern="1200">
+        <a:solidFill>
+          <a:schemeClr val="tx1"/>
+        </a:solidFill>
+        <a:latin typeface="+mn-lt"/>
+        <a:ea typeface="+mn-ea"/>
+        <a:cs typeface="+mn-cs"/>
+      </a:defRPr>
+    </a:lvl1pPr>
+    <a:lvl2pPr marL="457200" algn="l" defTabSz="457200" rtl="0" eaLnBrk="1" latinLnBrk="0" hangingPunct="1">
+      <a:defRPr sz="1200" kern="1200">
+        <a:solidFill>
+          <a:schemeClr val="tx1"/>
+        </a:solidFill>
+        <a:latin typeface="+mn-lt"/>
+        <a:ea typeface="+mn-ea"/>
+        <a:cs typeface="+mn-cs"/>
+      </a:defRPr>
+    </a:lvl2pPr>
+    <a:lvl3pPr marL="914400" algn="l" defTabSz="457200" rtl="0" eaLnBrk="1" latinLnBrk="0" hangingPunct="1">
+      <a:defRPr sz="1200" kern="1200">
+        <a:solidFill>
+          <a:schemeClr val="tx1"/>
+        </a:solidFill>
+        <a:latin typeface="+mn-lt"/>
+        <a:ea typeface="+mn-ea"/>
+        <a:cs typeface="+mn-cs"/>
+      </a:defRPr>
+    </a:lvl3pPr>
+    <a:lvl4pPr marL="1371600" algn="l" defTabSz="457200" rtl="0" eaLnBrk="1" latinLnBrk="0" hangingPunct="1">
+      <a:defRPr sz="1200" kern="1200">
+        <a:solidFill>
+          <a:schemeClr val="tx1"/>
+        </a:solidFill>
+        <a:latin typeface="+mn-lt"/>
+        <a:ea typeface="+mn-ea"/>
+        <a:cs typeface="+mn-cs"/>
+      </a:defRPr>
+    </a:lvl4pPr>
+    <a:lvl5pPr marL="1828800" algn="l" defTabSz="457200" rtl="0" eaLnBrk="1" latinLnBrk="0" hangingPunct="1">
+      <a:defRPr sz="1200" kern="1200">
+        <a:solidFill>
+          <a:schemeClr val="tx1"/>
+        </a:solidFill>
+        <a:latin typeface="+mn-lt"/>
+        <a:ea typeface="+mn-ea"/>
+        <a:cs typeface="+mn-cs"/>
+      </a:defRPr>
+    </a:lvl5pPr>
+    <a:lvl6pPr marL="2286000" algn="l" defTabSz="457200" rtl="0" eaLnBrk="1" latinLnBrk="0" hangingPunct="1">
+      <a:defRPr sz="1200" kern="1200">
+        <a:solidFill>
+          <a:schemeClr val="tx1"/>
+        </a:solidFill>
+        <a:latin typeface="+mn-lt"/>
+        <a:ea typeface="+mn-ea"/>
+        <a:cs typeface="+mn-cs"/>
+      </a:defRPr>
+    </a:lvl6pPr>
+    <a:lvl7pPr marL="2743200" algn="l" defTabSz="457200" rtl="0" eaLnBrk="1" latinLnBrk="0" hangingPunct="1">
+      <a:defRPr sz="1200" kern="1200">
+        <a:solidFill>
+          <a:schemeClr val="tx1"/>
+        </a:solidFill>
+        <a:latin typeface="+mn-lt"/>
+        <a:ea typeface="+mn-ea"/>
+        <a:cs typeface="+mn-cs"/>
+      </a:defRPr>
+    </a:lvl7pPr>
+    <a:lvl8pPr marL="3200400" algn="l" defTabSz="457200" rtl="0" eaLnBrk="1" latinLnBrk="0" hangingPunct="1">
+      <a:defRPr sz="1200" kern="1200">
+        <a:solidFill>
+          <a:schemeClr val="tx1"/>
+        </a:solidFill>
+        <a:latin typeface="+mn-lt"/>
+        <a:ea typeface="+mn-ea"/>
+        <a:cs typeface="+mn-cs"/>
+      </a:defRPr>
+    </a:lvl8pPr>
+    <a:lvl9pPr marL="3657600" algn="l" defTabSz="457200" rtl="0" eaLnBrk="1" latinLnBrk="0" hangingPunct="1">
+      <a:defRPr sz="1200" kern="1200">
+        <a:solidFill>
+          <a:schemeClr val="tx1"/>
+        </a:solidFill>
+        <a:latin typeface="+mn-lt"/>
+        <a:ea typeface="+mn-ea"/>
+        <a:cs typeface="+mn-cs"/>
+      </a:defRPr>
+    </a:lvl9pPr>
+  </p:notesStyle>
+</p:notesMaster>
+</file>
+
+<file path=ppt/notesSlides/notesSlide1.xml><?xml version="1.0" encoding="utf-8"?>
+<p:notes xmlns:a="http://schemas.openxmlformats.org/drawingml/2006/main" xmlns:p="http://schemas.openxmlformats.org/presentationml/2006/main" xmlns:r="http://schemas.openxmlformats.org/officeDocument/2006/relationships">
+  <p:cSld>
+    <p:spTree>
+      <p:nvGrpSpPr>
+        <p:cNvPr id="1" name=""/>
+        <p:cNvGrpSpPr/>
+        <p:nvPr/>
+      </p:nvGrpSpPr>
+      <p:grpSpPr>
+        <a:xfrm>
+          <a:off x="0" y="0"/>
+          <a:ext cx="0" cy="0"/>
+          <a:chOff x="0" y="0"/>
+          <a:chExt cx="0" cy="0"/>
+        </a:xfrm>
+      </p:grpSpPr>
+      <p:sp>
+        <p:nvSpPr>
+          <p:cNvPr id="2" name="Slide Image Placeholder 1"/>
+          <p:cNvSpPr>
+            <a:spLocks noGrp="1"/>
+          </p:cNvSpPr>
+          <p:nvPr>
+            <p:ph type="sldImg" idx="2"/>
+          </p:nvPr>
+        </p:nvSpPr>
+        <p:spPr/>
+      </p:sp>
+      <p:sp>
+        <p:nvSpPr>
+          <p:cNvPr id="3" name="Notes Placeholder 2"/>
+          <p:cNvSpPr>
+            <a:spLocks noGrp="1"/>
+          </p:cNvSpPr>
+          <p:nvPr>
+            <p:ph type="body" idx="3" sz="quarter"/>
+          </p:nvPr>
+        </p:nvSpPr>
+        <p:spPr/>
+        <p:txBody>
+          <a:bodyPr/>
+          <a:lstStyle/>
+          <a:p>
+            <a:r>
+              <a:t>Welcome everyone. Today we will walk through the modernization of a legacy COBOL accounting system into a modern Node.js application.</a:t>
+            </a:r>
+          </a:p>
+          <a:p/>
+          <a:p>
+            <a:r>
+              <a:t>This project demonstrates a complete end-to-end migration pipeline, taking a traditional mainframe-style COBOL program and converting it into a cloud-native Node.js application with full test coverage, Docker containerization, and CI/CD.</a:t>
+            </a:r>
+          </a:p>
+          <a:p/>
+          <a:p>
+            <a:r>
+              <a:t>The original system is a simple but representative account management application that handles credits, debits, and balance inquiries. While small in scope, it exercises the key patterns you encounter in real-world COBOL migrations: modular program structure, fixed-point arithmetic, synchronous I/O, and shared state through working storage.</a:t>
+            </a:r>
+          </a:p>
+        </p:txBody>
+      </p:sp>
+      <p:sp>
+        <p:nvSpPr>
+          <p:cNvPr id="4" name="Slide Number Placeholder 3"/>
+          <p:cNvSpPr>
+            <a:spLocks noGrp="1"/>
+          </p:cNvSpPr>
+          <p:nvPr>
+            <p:ph type="sldNum" idx="5" sz="quarter"/>
+          </p:nvPr>
+        </p:nvSpPr>
+        <p:spPr/>
+      </p:sp>
+    </p:spTree>
+  </p:cSld>
+  <p:clrMapOvr>
+    <a:masterClrMapping/>
+  </p:clrMapOvr>
+</p:notes>
+</file>
+
+<file path=ppt/notesSlides/notesSlide10.xml><?xml version="1.0" encoding="utf-8"?>
+<p:notes xmlns:a="http://schemas.openxmlformats.org/drawingml/2006/main" xmlns:p="http://schemas.openxmlformats.org/presentationml/2006/main" xmlns:r="http://schemas.openxmlformats.org/officeDocument/2006/relationships">
+  <p:cSld>
+    <p:spTree>
+      <p:nvGrpSpPr>
+        <p:cNvPr id="1" name=""/>
+        <p:cNvGrpSpPr/>
+        <p:nvPr/>
+      </p:nvGrpSpPr>
+      <p:grpSpPr>
+        <a:xfrm>
+          <a:off x="0" y="0"/>
+          <a:ext cx="0" cy="0"/>
+          <a:chOff x="0" y="0"/>
+          <a:chExt cx="0" cy="0"/>
+        </a:xfrm>
+      </p:grpSpPr>
+      <p:sp>
+        <p:nvSpPr>
+          <p:cNvPr id="2" name="Slide Image Placeholder 1"/>
+          <p:cNvSpPr>
+            <a:spLocks noGrp="1"/>
+          </p:cNvSpPr>
+          <p:nvPr>
+            <p:ph type="sldImg" idx="2"/>
+          </p:nvPr>
+        </p:nvSpPr>
+        <p:spPr/>
+      </p:sp>
+      <p:sp>
+        <p:nvSpPr>
+          <p:cNvPr id="3" name="Notes Placeholder 2"/>
+          <p:cNvSpPr>
+            <a:spLocks noGrp="1"/>
+          </p:cNvSpPr>
+          <p:nvPr>
+            <p:ph type="body" idx="3" sz="quarter"/>
+          </p:nvPr>
+        </p:nvSpPr>
+        <p:spPr/>
+        <p:txBody>
+          <a:bodyPr/>
+          <a:lstStyle/>
+          <a:p>
+            <a:r>
+              <a:t>To summarize what we achieved: we successfully converted all three COBOL source files into three Node.js modules, maintaining the original modular architecture.</a:t>
+            </a:r>
+          </a:p>
+          <a:p/>
+          <a:p>
+            <a:r>
+              <a:t>We have 26 passing tests covering both unit and integration scenarios, with 100 percent coverage on the business logic modules. The application is fully containerized with Docker and has a complete CI/CD pipeline using GitHub Actions.</a:t>
+            </a:r>
+          </a:p>
+          <a:p/>
+          <a:p>
+            <a:r>
+              <a:t>Looking ahead, there are several natural next steps. Adding a REST API layer with Express.js would make the application accessible over HTTP instead of just the terminal. Replacing the in-memory store with PostgreSQL would add persistence across restarts. Authentication and authorization would be needed for a multi-user environment.</a:t>
+            </a:r>
+          </a:p>
+          <a:p/>
+          <a:p>
+            <a:r>
+              <a:t>Transaction history and audit logging would provide accountability, which is especially important for financial applications. Monitoring and alerting would ensure we know about issues before users do. And finally, performance benchmarking against the original COBOL system would give us concrete data on how the modernized version compares.</a:t>
+            </a:r>
+          </a:p>
+          <a:p/>
+          <a:p>
+            <a:r>
+              <a:t>Thank you for your time. I am happy to answer any questions about the migration process, the technical decisions, or the next steps.</a:t>
+            </a:r>
+          </a:p>
+        </p:txBody>
+      </p:sp>
+      <p:sp>
+        <p:nvSpPr>
+          <p:cNvPr id="4" name="Slide Number Placeholder 3"/>
+          <p:cNvSpPr>
+            <a:spLocks noGrp="1"/>
+          </p:cNvSpPr>
+          <p:nvPr>
+            <p:ph type="sldNum" idx="5" sz="quarter"/>
+          </p:nvPr>
+        </p:nvSpPr>
+        <p:spPr/>
+      </p:sp>
+    </p:spTree>
+  </p:cSld>
+  <p:clrMapOvr>
+    <a:masterClrMapping/>
+  </p:clrMapOvr>
+</p:notes>
+</file>
+
+<file path=ppt/notesSlides/notesSlide2.xml><?xml version="1.0" encoding="utf-8"?>
+<p:notes xmlns:a="http://schemas.openxmlformats.org/drawingml/2006/main" xmlns:p="http://schemas.openxmlformats.org/presentationml/2006/main" xmlns:r="http://schemas.openxmlformats.org/officeDocument/2006/relationships">
+  <p:cSld>
+    <p:spTree>
+      <p:nvGrpSpPr>
+        <p:cNvPr id="1" name=""/>
+        <p:cNvGrpSpPr/>
+        <p:nvPr/>
+      </p:nvGrpSpPr>
+      <p:grpSpPr>
+        <a:xfrm>
+          <a:off x="0" y="0"/>
+          <a:ext cx="0" cy="0"/>
+          <a:chOff x="0" y="0"/>
+          <a:chExt cx="0" cy="0"/>
+        </a:xfrm>
+      </p:grpSpPr>
+      <p:sp>
+        <p:nvSpPr>
+          <p:cNvPr id="2" name="Slide Image Placeholder 1"/>
+          <p:cNvSpPr>
+            <a:spLocks noGrp="1"/>
+          </p:cNvSpPr>
+          <p:nvPr>
+            <p:ph type="sldImg" idx="2"/>
+          </p:nvPr>
+        </p:nvSpPr>
+        <p:spPr/>
+      </p:sp>
+      <p:sp>
+        <p:nvSpPr>
+          <p:cNvPr id="3" name="Notes Placeholder 2"/>
+          <p:cNvSpPr>
+            <a:spLocks noGrp="1"/>
+          </p:cNvSpPr>
+          <p:nvPr>
+            <p:ph type="body" idx="3" sz="quarter"/>
+          </p:nvPr>
+        </p:nvSpPr>
+        <p:spPr/>
+        <p:txBody>
+          <a:bodyPr/>
+          <a:lstStyle/>
+          <a:p>
+            <a:r>
+              <a:t>Here is our agenda for today. We will start by reviewing the legacy COBOL system to understand what we are working with. Then we will cover the modernization strategy we chose and why.</a:t>
+            </a:r>
+          </a:p>
+          <a:p/>
+          <a:p>
+            <a:r>
+              <a:t>The core of the presentation covers the architecture mapping between COBOL and Node.js, followed by a concrete code conversion example so you can see the before-and-after side by side.</a:t>
+            </a:r>
+          </a:p>
+          <a:p/>
+          <a:p>
+            <a:r>
+              <a:t>We will then discuss our testing strategy, which was critical for validating that the Node.js version behaves identically to the COBOL original. After that, we will review the deployment pipeline and the key technical decisions we made along the way.</a:t>
+            </a:r>
+          </a:p>
+          <a:p/>
+          <a:p>
+            <a:r>
+              <a:t>Finally, we will wrap up with results and next steps for further modernization.</a:t>
+            </a:r>
+          </a:p>
+        </p:txBody>
+      </p:sp>
+      <p:sp>
+        <p:nvSpPr>
+          <p:cNvPr id="4" name="Slide Number Placeholder 3"/>
+          <p:cNvSpPr>
+            <a:spLocks noGrp="1"/>
+          </p:cNvSpPr>
+          <p:nvPr>
+            <p:ph type="sldNum" idx="5" sz="quarter"/>
+          </p:nvPr>
+        </p:nvSpPr>
+        <p:spPr/>
+      </p:sp>
+    </p:spTree>
+  </p:cSld>
+  <p:clrMapOvr>
+    <a:masterClrMapping/>
+  </p:clrMapOvr>
+</p:notes>
+</file>
+
+<file path=ppt/notesSlides/notesSlide3.xml><?xml version="1.0" encoding="utf-8"?>
+<p:notes xmlns:a="http://schemas.openxmlformats.org/drawingml/2006/main" xmlns:p="http://schemas.openxmlformats.org/presentationml/2006/main" xmlns:r="http://schemas.openxmlformats.org/officeDocument/2006/relationships">
+  <p:cSld>
+    <p:spTree>
+      <p:nvGrpSpPr>
+        <p:cNvPr id="1" name=""/>
+        <p:cNvGrpSpPr/>
+        <p:nvPr/>
+      </p:nvGrpSpPr>
+      <p:grpSpPr>
+        <a:xfrm>
+          <a:off x="0" y="0"/>
+          <a:ext cx="0" cy="0"/>
+          <a:chOff x="0" y="0"/>
+          <a:chExt cx="0" cy="0"/>
+        </a:xfrm>
+      </p:grpSpPr>
+      <p:sp>
+        <p:nvSpPr>
+          <p:cNvPr id="2" name="Slide Image Placeholder 1"/>
+          <p:cNvSpPr>
+            <a:spLocks noGrp="1"/>
+          </p:cNvSpPr>
+          <p:nvPr>
+            <p:ph type="sldImg" idx="2"/>
+          </p:nvPr>
+        </p:nvSpPr>
+        <p:spPr/>
+      </p:sp>
+      <p:sp>
+        <p:nvSpPr>
+          <p:cNvPr id="3" name="Notes Placeholder 2"/>
+          <p:cNvSpPr>
+            <a:spLocks noGrp="1"/>
+          </p:cNvSpPr>
+          <p:nvPr>
+            <p:ph type="body" idx="3" sz="quarter"/>
+          </p:nvPr>
+        </p:nvSpPr>
+        <p:spPr/>
+        <p:txBody>
+          <a:bodyPr/>
+          <a:lstStyle/>
+          <a:p>
+            <a:r>
+              <a:t>Let us look at the legacy system we are modernizing. The application is written in GnuCOBOL and follows a classic 3-tier modular architecture.</a:t>
+            </a:r>
+          </a:p>
+          <a:p/>
+          <a:p>
+            <a:r>
+              <a:t>The three source files each have a clear responsibility: main.cob handles the terminal menu and user interaction loop, operations.cob contains all the business logic for crediting, debiting, and viewing the balance, and data.cob acts as the data access layer managing the stored balance.</a:t>
+            </a:r>
+          </a:p>
+          <a:p/>
+          <a:p>
+            <a:r>
+              <a:t>A key detail is the data format. COBOL uses PIC 9(6)V99, which is a fixed-point decimal format with six integer digits and two decimal places. This means all arithmetic is done in exact decimal, with no floating-point rounding issues. Preserving this precision in Node.js was one of our main technical challenges.</a:t>
+            </a:r>
+          </a:p>
+          <a:p/>
+          <a:p>
+            <a:r>
+              <a:t>The system starts with an initial balance of $1,000.00 and provides four operations: view balance, credit the account, debit the account with insufficient funds protection, and exit.</a:t>
+            </a:r>
+          </a:p>
+        </p:txBody>
+      </p:sp>
+      <p:sp>
+        <p:nvSpPr>
+          <p:cNvPr id="4" name="Slide Number Placeholder 3"/>
+          <p:cNvSpPr>
+            <a:spLocks noGrp="1"/>
+          </p:cNvSpPr>
+          <p:nvPr>
+            <p:ph type="sldNum" idx="5" sz="quarter"/>
+          </p:nvPr>
+        </p:nvSpPr>
+        <p:spPr/>
+      </p:sp>
+    </p:spTree>
+  </p:cSld>
+  <p:clrMapOvr>
+    <a:masterClrMapping/>
+  </p:clrMapOvr>
+</p:notes>
+</file>
+
+<file path=ppt/notesSlides/notesSlide4.xml><?xml version="1.0" encoding="utf-8"?>
+<p:notes xmlns:a="http://schemas.openxmlformats.org/drawingml/2006/main" xmlns:p="http://schemas.openxmlformats.org/presentationml/2006/main" xmlns:r="http://schemas.openxmlformats.org/officeDocument/2006/relationships">
+  <p:cSld>
+    <p:spTree>
+      <p:nvGrpSpPr>
+        <p:cNvPr id="1" name=""/>
+        <p:cNvGrpSpPr/>
+        <p:nvPr/>
+      </p:nvGrpSpPr>
+      <p:grpSpPr>
+        <a:xfrm>
+          <a:off x="0" y="0"/>
+          <a:ext cx="0" cy="0"/>
+          <a:chOff x="0" y="0"/>
+          <a:chExt cx="0" cy="0"/>
+        </a:xfrm>
+      </p:grpSpPr>
+      <p:sp>
+        <p:nvSpPr>
+          <p:cNvPr id="2" name="Slide Image Placeholder 1"/>
+          <p:cNvSpPr>
+            <a:spLocks noGrp="1"/>
+          </p:cNvSpPr>
+          <p:nvPr>
+            <p:ph type="sldImg" idx="2"/>
+          </p:nvPr>
+        </p:nvSpPr>
+        <p:spPr/>
+      </p:sp>
+      <p:sp>
+        <p:nvSpPr>
+          <p:cNvPr id="3" name="Notes Placeholder 2"/>
+          <p:cNvSpPr>
+            <a:spLocks noGrp="1"/>
+          </p:cNvSpPr>
+          <p:nvPr>
+            <p:ph type="body" idx="3" sz="quarter"/>
+          </p:nvPr>
+        </p:nvSpPr>
+        <p:spPr/>
+        <p:txBody>
+          <a:bodyPr/>
+          <a:lstStyle/>
+          <a:p>
+            <a:r>
+              <a:t>Our modernization strategy was built around five key principles.</a:t>
+            </a:r>
+          </a:p>
+          <a:p/>
+          <a:p>
+            <a:r>
+              <a:t>First, file-for-file migration. Rather than rewriting the entire application from scratch, we mapped each COBOL source file to exactly one Node.js module. This preserves the original separation of concerns and makes it easy to trace how each piece of the COBOL system maps to the new codebase.</a:t>
+            </a:r>
+          </a:p>
+          <a:p/>
+          <a:p>
+            <a:r>
+              <a:t>Second, behavior preservation. The business logic and validation rules in Node.js are identical to the COBOL version. If the COBOL system rejects an overdraft, the Node.js version must reject it with the same message and leave the balance unchanged.</a:t>
+            </a:r>
+          </a:p>
+          <a:p/>
+          <a:p>
+            <a:r>
+              <a:t>Third, test-driven validation. We created a comprehensive test suite based on the existing TESTPLAN.md to verify that every scenario behaves exactly as it did in COBOL. This gives us confidence that the migration is faithful.</a:t>
+            </a:r>
+          </a:p>
+          <a:p/>
+          <a:p>
+            <a:r>
+              <a:t>Fourth, incremental deployment using Docker, so we can roll out gradually from development to staging to production. And fifth, documentation was created alongside the code, not as an afterthought.</a:t>
+            </a:r>
+          </a:p>
+        </p:txBody>
+      </p:sp>
+      <p:sp>
+        <p:nvSpPr>
+          <p:cNvPr id="4" name="Slide Number Placeholder 3"/>
+          <p:cNvSpPr>
+            <a:spLocks noGrp="1"/>
+          </p:cNvSpPr>
+          <p:nvPr>
+            <p:ph type="sldNum" idx="5" sz="quarter"/>
+          </p:nvPr>
+        </p:nvSpPr>
+        <p:spPr/>
+      </p:sp>
+    </p:spTree>
+  </p:cSld>
+  <p:clrMapOvr>
+    <a:masterClrMapping/>
+  </p:clrMapOvr>
+</p:notes>
+</file>
+
+<file path=ppt/notesSlides/notesSlide5.xml><?xml version="1.0" encoding="utf-8"?>
+<p:notes xmlns:a="http://schemas.openxmlformats.org/drawingml/2006/main" xmlns:p="http://schemas.openxmlformats.org/presentationml/2006/main" xmlns:r="http://schemas.openxmlformats.org/officeDocument/2006/relationships">
+  <p:cSld>
+    <p:spTree>
+      <p:nvGrpSpPr>
+        <p:cNvPr id="1" name=""/>
+        <p:cNvGrpSpPr/>
+        <p:nvPr/>
+      </p:nvGrpSpPr>
+      <p:grpSpPr>
+        <a:xfrm>
+          <a:off x="0" y="0"/>
+          <a:ext cx="0" cy="0"/>
+          <a:chOff x="0" y="0"/>
+          <a:chExt cx="0" cy="0"/>
+        </a:xfrm>
+      </p:grpSpPr>
+      <p:sp>
+        <p:nvSpPr>
+          <p:cNvPr id="2" name="Slide Image Placeholder 1"/>
+          <p:cNvSpPr>
+            <a:spLocks noGrp="1"/>
+          </p:cNvSpPr>
+          <p:nvPr>
+            <p:ph type="sldImg" idx="2"/>
+          </p:nvPr>
+        </p:nvSpPr>
+        <p:spPr/>
+      </p:sp>
+      <p:sp>
+        <p:nvSpPr>
+          <p:cNvPr id="3" name="Notes Placeholder 2"/>
+          <p:cNvSpPr>
+            <a:spLocks noGrp="1"/>
+          </p:cNvSpPr>
+          <p:nvPr>
+            <p:ph type="body" idx="3" sz="quarter"/>
+          </p:nvPr>
+        </p:nvSpPr>
+        <p:spPr/>
+        <p:txBody>
+          <a:bodyPr/>
+          <a:lstStyle/>
+          <a:p>
+            <a:r>
+              <a:t>This table shows the detailed mapping between COBOL constructs and their Node.js equivalents.</a:t>
+            </a:r>
+          </a:p>
+          <a:p/>
+          <a:p>
+            <a:r>
+              <a:t>The three source files map one-to-one: main.cob becomes src/main.js, operations.cob becomes src/operations.js, and data.cob becomes src/data.js. Each module retains its original responsibility.</a:t>
+            </a:r>
+          </a:p>
+          <a:p/>
+          <a:p>
+            <a:r>
+              <a:t>For the data format, COBOL's PIC 9(6)V99 fixed-point type is replicated using Math.round(x * 100) / 100 in JavaScript. This ensures we get the same two-decimal precision without floating-point drift. For example, in raw JavaScript, 0.1 + 0.2 equals 0.30000000000000004, but our rounding approach correctly produces 0.30.</a:t>
+            </a:r>
+          </a:p>
+          <a:p/>
+          <a:p>
+            <a:r>
+              <a:t>COBOL's CALL statement, which invokes subprograms by name, maps naturally to Node.js require() for module imports. And COBOL's ACCEPT statement for terminal input is replaced by the readline-sync library, which provides the same synchronous, blocking I/O behavior.</a:t>
+            </a:r>
+          </a:p>
+        </p:txBody>
+      </p:sp>
+      <p:sp>
+        <p:nvSpPr>
+          <p:cNvPr id="4" name="Slide Number Placeholder 3"/>
+          <p:cNvSpPr>
+            <a:spLocks noGrp="1"/>
+          </p:cNvSpPr>
+          <p:nvPr>
+            <p:ph type="sldNum" idx="5" sz="quarter"/>
+          </p:nvPr>
+        </p:nvSpPr>
+        <p:spPr/>
+      </p:sp>
+    </p:spTree>
+  </p:cSld>
+  <p:clrMapOvr>
+    <a:masterClrMapping/>
+  </p:clrMapOvr>
+</p:notes>
+</file>
+
+<file path=ppt/notesSlides/notesSlide6.xml><?xml version="1.0" encoding="utf-8"?>
+<p:notes xmlns:a="http://schemas.openxmlformats.org/drawingml/2006/main" xmlns:p="http://schemas.openxmlformats.org/presentationml/2006/main" xmlns:r="http://schemas.openxmlformats.org/officeDocument/2006/relationships">
+  <p:cSld>
+    <p:spTree>
+      <p:nvGrpSpPr>
+        <p:cNvPr id="1" name=""/>
+        <p:cNvGrpSpPr/>
+        <p:nvPr/>
+      </p:nvGrpSpPr>
+      <p:grpSpPr>
+        <a:xfrm>
+          <a:off x="0" y="0"/>
+          <a:ext cx="0" cy="0"/>
+          <a:chOff x="0" y="0"/>
+          <a:chExt cx="0" cy="0"/>
+        </a:xfrm>
+      </p:grpSpPr>
+      <p:sp>
+        <p:nvSpPr>
+          <p:cNvPr id="2" name="Slide Image Placeholder 1"/>
+          <p:cNvSpPr>
+            <a:spLocks noGrp="1"/>
+          </p:cNvSpPr>
+          <p:nvPr>
+            <p:ph type="sldImg" idx="2"/>
+          </p:nvPr>
+        </p:nvSpPr>
+        <p:spPr/>
+      </p:sp>
+      <p:sp>
+        <p:nvSpPr>
+          <p:cNvPr id="3" name="Notes Placeholder 2"/>
+          <p:cNvSpPr>
+            <a:spLocks noGrp="1"/>
+          </p:cNvSpPr>
+          <p:nvPr>
+            <p:ph type="body" idx="3" sz="quarter"/>
+          </p:nvPr>
+        </p:nvSpPr>
+        <p:spPr/>
+        <p:txBody>
+          <a:bodyPr/>
+          <a:lstStyle/>
+          <a:p>
+            <a:r>
+              <a:t>Let us look at a concrete code conversion example. Here we compare the debit operation side by side, COBOL on the left and Node.js on the right.</a:t>
+            </a:r>
+          </a:p>
+          <a:p/>
+          <a:p>
+            <a:r>
+              <a:t>In the COBOL version, the program accepts the debit amount from the terminal, reads the current balance from the data program, checks if there are sufficient funds, and either subtracts the amount and writes the new balance, or displays an insufficient funds message.</a:t>
+            </a:r>
+          </a:p>
+          <a:p/>
+          <a:p>
+            <a:r>
+              <a:t>The Node.js version follows the exact same logic flow. Notice how the function first rounds the input amount to two decimal places using Math.round, reads the balance from the data module, performs the same greater-than-or-equal check, and returns a result object.</a:t>
+            </a:r>
+          </a:p>
+          <a:p/>
+          <a:p>
+            <a:r>
+              <a:t>One key improvement in the Node.js version is that functions return result objects with balance and message properties instead of printing directly to the console. This makes the business logic fully testable without needing to mock console.log. The success flag in the return value makes it easy for callers to check whether the debit was approved or rejected.</a:t>
+            </a:r>
+          </a:p>
+        </p:txBody>
+      </p:sp>
+      <p:sp>
+        <p:nvSpPr>
+          <p:cNvPr id="4" name="Slide Number Placeholder 3"/>
+          <p:cNvSpPr>
+            <a:spLocks noGrp="1"/>
+          </p:cNvSpPr>
+          <p:nvPr>
+            <p:ph type="sldNum" idx="5" sz="quarter"/>
+          </p:nvPr>
+        </p:nvSpPr>
+        <p:spPr/>
+      </p:sp>
+    </p:spTree>
+  </p:cSld>
+  <p:clrMapOvr>
+    <a:masterClrMapping/>
+  </p:clrMapOvr>
+</p:notes>
+</file>
+
+<file path=ppt/notesSlides/notesSlide7.xml><?xml version="1.0" encoding="utf-8"?>
+<p:notes xmlns:a="http://schemas.openxmlformats.org/drawingml/2006/main" xmlns:p="http://schemas.openxmlformats.org/presentationml/2006/main" xmlns:r="http://schemas.openxmlformats.org/officeDocument/2006/relationships">
+  <p:cSld>
+    <p:spTree>
+      <p:nvGrpSpPr>
+        <p:cNvPr id="1" name=""/>
+        <p:cNvGrpSpPr/>
+        <p:nvPr/>
+      </p:nvGrpSpPr>
+      <p:grpSpPr>
+        <a:xfrm>
+          <a:off x="0" y="0"/>
+          <a:ext cx="0" cy="0"/>
+          <a:chOff x="0" y="0"/>
+          <a:chExt cx="0" cy="0"/>
+        </a:xfrm>
+      </p:grpSpPr>
+      <p:sp>
+        <p:nvSpPr>
+          <p:cNvPr id="2" name="Slide Image Placeholder 1"/>
+          <p:cNvSpPr>
+            <a:spLocks noGrp="1"/>
+          </p:cNvSpPr>
+          <p:nvPr>
+            <p:ph type="sldImg" idx="2"/>
+          </p:nvPr>
+        </p:nvSpPr>
+        <p:spPr/>
+      </p:sp>
+      <p:sp>
+        <p:nvSpPr>
+          <p:cNvPr id="3" name="Notes Placeholder 2"/>
+          <p:cNvSpPr>
+            <a:spLocks noGrp="1"/>
+          </p:cNvSpPr>
+          <p:nvPr>
+            <p:ph type="body" idx="3" sz="quarter"/>
+          </p:nvPr>
+        </p:nvSpPr>
+        <p:spPr/>
+        <p:txBody>
+          <a:bodyPr/>
+          <a:lstStyle/>
+          <a:p>
+            <a:r>
+              <a:t>Testing was a critical part of this migration. We needed to prove that the Node.js application behaves identically to the COBOL original in every scenario.</a:t>
+            </a:r>
+          </a:p>
+          <a:p/>
+          <a:p>
+            <a:r>
+              <a:t>We built 26 tests across 3 test suites using Jest, achieving 100 percent coverage on the data and operations modules. The test cases were derived directly from the existing TESTPLAN.md document, ensuring traceability back to the original business requirements.</a:t>
+            </a:r>
+          </a:p>
+          <a:p/>
+          <a:p>
+            <a:r>
+              <a:t>The unit tests for the data module verify basic read, write, and reset operations. The operations module tests cover all the core scenarios: viewing the balance, crediting with valid and zero amounts, debiting with valid amounts, handling insufficient funds, and debiting with zero.</a:t>
+            </a:r>
+          </a:p>
+          <a:p/>
+          <a:p>
+            <a:r>
+              <a:t>The integration tests go further by simulating complete user sessions. For example, the full workflow test performs a view, then a credit, then a debit, and verifies the balance at each step. We also test edge cases like draining the account to zero and then recovering with a credit, which validates that state persists correctly across module boundaries.</a:t>
+            </a:r>
+          </a:p>
+          <a:p/>
+          <a:p>
+            <a:r>
+              <a:t>We also verified floating-point precision specifically. Crediting 0.1 + 0.2 must produce exactly 0.30, not 0.30000000000000004.</a:t>
+            </a:r>
+          </a:p>
+        </p:txBody>
+      </p:sp>
+      <p:sp>
+        <p:nvSpPr>
+          <p:cNvPr id="4" name="Slide Number Placeholder 3"/>
+          <p:cNvSpPr>
+            <a:spLocks noGrp="1"/>
+          </p:cNvSpPr>
+          <p:nvPr>
+            <p:ph type="sldNum" idx="5" sz="quarter"/>
+          </p:nvPr>
+        </p:nvSpPr>
+        <p:spPr/>
+      </p:sp>
+    </p:spTree>
+  </p:cSld>
+  <p:clrMapOvr>
+    <a:masterClrMapping/>
+  </p:clrMapOvr>
+</p:notes>
+</file>
+
+<file path=ppt/notesSlides/notesSlide8.xml><?xml version="1.0" encoding="utf-8"?>
+<p:notes xmlns:a="http://schemas.openxmlformats.org/drawingml/2006/main" xmlns:p="http://schemas.openxmlformats.org/presentationml/2006/main" xmlns:r="http://schemas.openxmlformats.org/officeDocument/2006/relationships">
+  <p:cSld>
+    <p:spTree>
+      <p:nvGrpSpPr>
+        <p:cNvPr id="1" name=""/>
+        <p:cNvGrpSpPr/>
+        <p:nvPr/>
+      </p:nvGrpSpPr>
+      <p:grpSpPr>
+        <a:xfrm>
+          <a:off x="0" y="0"/>
+          <a:ext cx="0" cy="0"/>
+          <a:chOff x="0" y="0"/>
+          <a:chExt cx="0" cy="0"/>
+        </a:xfrm>
+      </p:grpSpPr>
+      <p:sp>
+        <p:nvSpPr>
+          <p:cNvPr id="2" name="Slide Image Placeholder 1"/>
+          <p:cNvSpPr>
+            <a:spLocks noGrp="1"/>
+          </p:cNvSpPr>
+          <p:nvPr>
+            <p:ph type="sldImg" idx="2"/>
+          </p:nvPr>
+        </p:nvSpPr>
+        <p:spPr/>
+      </p:sp>
+      <p:sp>
+        <p:nvSpPr>
+          <p:cNvPr id="3" name="Notes Placeholder 2"/>
+          <p:cNvSpPr>
+            <a:spLocks noGrp="1"/>
+          </p:cNvSpPr>
+          <p:nvPr>
+            <p:ph type="body" idx="3" sz="quarter"/>
+          </p:nvPr>
+        </p:nvSpPr>
+        <p:spPr/>
+        <p:txBody>
+          <a:bodyPr/>
+          <a:lstStyle/>
+          <a:p>
+            <a:r>
+              <a:t>Our deployment pipeline has seven stages, all automated through a single deploy script.</a:t>
+            </a:r>
+          </a:p>
+          <a:p/>
+          <a:p>
+            <a:r>
+              <a:t>First, we validate the environment: checking that Node.js 18 or higher is installed, that npm is available, and that Docker is present for staging and production deployments.</a:t>
+            </a:r>
+          </a:p>
+          <a:p/>
+          <a:p>
+            <a:r>
+              <a:t>Then we do a clean install of dependencies with npm ci, which ensures reproducible builds from the lockfile. Next, ESLint runs static analysis to catch code quality issues before any tests run.</a:t>
+            </a:r>
+          </a:p>
+          <a:p/>
+          <a:p>
+            <a:r>
+              <a:t>The test stage runs the full Jest suite with coverage reporting. If any test fails, the pipeline stops immediately so we never deploy broken code.</a:t>
+            </a:r>
+          </a:p>
+          <a:p/>
+          <a:p>
+            <a:r>
+              <a:t>For staging and production, we build a Docker image using a multi-stage Alpine build. The first stage installs production dependencies, and the second stage creates a minimal runtime image with a non-root user for security. The image includes health checks for container orchestration.</a:t>
+            </a:r>
+          </a:p>
+          <a:p/>
+          <a:p>
+            <a:r>
+              <a:t>The push stage sends the image to a container registry like GitHub Container Registry, and finally the deploy stage runs the container with appropriate resource limits and restart policies.</a:t>
+            </a:r>
+          </a:p>
+          <a:p/>
+          <a:p>
+            <a:r>
+              <a:t>The entire pipeline is invoked with a single command: deploy.sh followed by the environment name. In development mode, it skips Docker and runs directly.</a:t>
+            </a:r>
+          </a:p>
+        </p:txBody>
+      </p:sp>
+      <p:sp>
+        <p:nvSpPr>
+          <p:cNvPr id="4" name="Slide Number Placeholder 3"/>
+          <p:cNvSpPr>
+            <a:spLocks noGrp="1"/>
+          </p:cNvSpPr>
+          <p:nvPr>
+            <p:ph type="sldNum" idx="5" sz="quarter"/>
+          </p:nvPr>
+        </p:nvSpPr>
+        <p:spPr/>
+      </p:sp>
+    </p:spTree>
+  </p:cSld>
+  <p:clrMapOvr>
+    <a:masterClrMapping/>
+  </p:clrMapOvr>
+</p:notes>
+</file>
+
+<file path=ppt/notesSlides/notesSlide9.xml><?xml version="1.0" encoding="utf-8"?>
+<p:notes xmlns:a="http://schemas.openxmlformats.org/drawingml/2006/main" xmlns:p="http://schemas.openxmlformats.org/presentationml/2006/main" xmlns:r="http://schemas.openxmlformats.org/officeDocument/2006/relationships">
+  <p:cSld>
+    <p:spTree>
+      <p:nvGrpSpPr>
+        <p:cNvPr id="1" name=""/>
+        <p:cNvGrpSpPr/>
+        <p:nvPr/>
+      </p:nvGrpSpPr>
+      <p:grpSpPr>
+        <a:xfrm>
+          <a:off x="0" y="0"/>
+          <a:ext cx="0" cy="0"/>
+          <a:chOff x="0" y="0"/>
+          <a:chExt cx="0" cy="0"/>
+        </a:xfrm>
+      </p:grpSpPr>
+      <p:sp>
+        <p:nvSpPr>
+          <p:cNvPr id="2" name="Slide Image Placeholder 1"/>
+          <p:cNvSpPr>
+            <a:spLocks noGrp="1"/>
+          </p:cNvSpPr>
+          <p:nvPr>
+            <p:ph type="sldImg" idx="2"/>
+          </p:nvPr>
+        </p:nvSpPr>
+        <p:spPr/>
+      </p:sp>
+      <p:sp>
+        <p:nvSpPr>
+          <p:cNvPr id="3" name="Notes Placeholder 2"/>
+          <p:cNvSpPr>
+            <a:spLocks noGrp="1"/>
+          </p:cNvSpPr>
+          <p:nvPr>
+            <p:ph type="body" idx="3" sz="quarter"/>
+          </p:nvPr>
+        </p:nvSpPr>
+        <p:spPr/>
+        <p:txBody>
+          <a:bodyPr/>
+          <a:lstStyle/>
+          <a:p>
+            <a:r>
+              <a:t>Let me walk through the key technical decisions we made and the reasoning behind each one.</a:t>
+            </a:r>
+          </a:p>
+          <a:p/>
+          <a:p>
+            <a:r>
+              <a:t>We chose readline-sync for terminal I/O because it provides synchronous, blocking input, which matches how COBOL's ACCEPT statement works. This keeps the migration faithful to the original. In a future phase, we could swap this for an async API layer using Express.js without changing the business logic.</a:t>
+            </a:r>
+          </a:p>
+          <a:p/>
+          <a:p>
+            <a:r>
+              <a:t>For data storage, we kept an in-memory variable, mirroring COBOL's working-storage section. This is intentional for the migration phase. The data module provides a clean interface with readBalance and writeBalance, so swapping in a real database later is a straightforward change.</a:t>
+            </a:r>
+          </a:p>
+          <a:p/>
+          <a:p>
+            <a:r>
+              <a:t>Math.round for precision was essential. JavaScript uses IEEE 754 floating-point, which can produce tiny rounding errors. Our approach of rounding to two decimal places after every calculation replicates COBOL's fixed-point behavior exactly.</a:t>
+            </a:r>
+          </a:p>
+          <a:p/>
+          <a:p>
+            <a:r>
+              <a:t>Jest was selected for testing because it is the industry standard for Node.js, has excellent coverage reporting, and its test case structure maps naturally to our existing TESTPLAN.md.</a:t>
+            </a:r>
+          </a:p>
+          <a:p/>
+          <a:p>
+            <a:r>
+              <a:t>The Docker multi-stage build produces a minimal Alpine-based image, runs as a non-root user for security, and includes health checks so container orchestrators can monitor the application. The GitHub Actions pipeline tests against both Node 18 and 20 to ensure forward compatibility.</a:t>
+            </a:r>
+          </a:p>
+        </p:txBody>
+      </p:sp>
+      <p:sp>
+        <p:nvSpPr>
+          <p:cNvPr id="4" name="Slide Number Placeholder 3"/>
+          <p:cNvSpPr>
+            <a:spLocks noGrp="1"/>
+          </p:cNvSpPr>
+          <p:nvPr>
+            <p:ph type="sldNum" idx="5" sz="quarter"/>
+          </p:nvPr>
+        </p:nvSpPr>
+        <p:spPr/>
+      </p:sp>
+    </p:spTree>
+  </p:cSld>
+  <p:clrMapOvr>
+    <a:masterClrMapping/>
+  </p:clrMapOvr>
+</p:notes>
 </file>
 
 <file path=ppt/slideLayouts/slideLayout1.xml><?xml version="1.0" encoding="utf-8"?>
@@ -7534,4 +8806,324 @@
   </a:objectDefaults>
   <a:extraClrSchemeLst/>
 </a:theme>
+</file>
+
+<file path=ppt/theme/theme2.xml><?xml version="1.0" encoding="utf-8"?>
+<a:theme xmlns:a="http://schemas.openxmlformats.org/drawingml/2006/main" name="Office Theme">
+  <a:themeElements>
+    <a:clrScheme name="Office">
+      <a:dk1>
+        <a:sysClr val="windowText" lastClr="000000"/>
+      </a:dk1>
+      <a:lt1>
+        <a:sysClr val="window" lastClr="FFFFFF"/>
+      </a:lt1>
+      <a:dk2>
+        <a:srgbClr val="1F497D"/>
+      </a:dk2>
+      <a:lt2>
+        <a:srgbClr val="EEECE1"/>
+      </a:lt2>
+      <a:accent1>
+        <a:srgbClr val="4F81BD"/>
+      </a:accent1>
+      <a:accent2>
+        <a:srgbClr val="C0504D"/>
+      </a:accent2>
+      <a:accent3>
+        <a:srgbClr val="9BBB59"/>
+      </a:accent3>
+      <a:accent4>
+        <a:srgbClr val="8064A2"/>
+      </a:accent4>
+      <a:accent5>
+        <a:srgbClr val="4BACC6"/>
+      </a:accent5>
+      <a:accent6>
+        <a:srgbClr val="F79646"/>
+      </a:accent6>
+      <a:hlink>
+        <a:srgbClr val="0000FF"/>
+      </a:hlink>
+      <a:folHlink>
+        <a:srgbClr val="800080"/>
+      </a:folHlink>
+    </a:clrScheme>
+    <a:fontScheme name="Office">
+      <a:majorFont>
+        <a:latin typeface="Calibri"/>
+        <a:ea typeface=""/>
+        <a:cs typeface=""/>
+        <a:font script="Jpan" typeface="ＭＳ Ｐゴシック"/>
+        <a:font script="Hang" typeface="맑은 고딕"/>
+        <a:font script="Hans" typeface="宋体"/>
+        <a:font script="Hant" typeface="新細明體"/>
+        <a:font script="Arab" typeface="Times New Roman"/>
+        <a:font script="Hebr" typeface="Times New Roman"/>
+        <a:font script="Thai" typeface="Angsana New"/>
+        <a:font script="Ethi" typeface="Nyala"/>
+        <a:font script="Beng" typeface="Vrinda"/>
+        <a:font script="Gujr" typeface="Shruti"/>
+        <a:font script="Khmr" typeface="MoolBoran"/>
+        <a:font script="Knda" typeface="Tunga"/>
+        <a:font script="Guru" typeface="Raavi"/>
+        <a:font script="Cans" typeface="Euphemia"/>
+        <a:font script="Cher" typeface="Plantagenet Cherokee"/>
+        <a:font script="Yiii" typeface="Microsoft Yi Baiti"/>
+        <a:font script="Tibt" typeface="Microsoft Himalaya"/>
+        <a:font script="Thaa" typeface="MV Boli"/>
+        <a:font script="Deva" typeface="Mangal"/>
+        <a:font script="Telu" typeface="Gautami"/>
+        <a:font script="Taml" typeface="Latha"/>
+        <a:font script="Syrc" typeface="Estrangelo Edessa"/>
+        <a:font script="Orya" typeface="Kalinga"/>
+        <a:font script="Mlym" typeface="Kartika"/>
+        <a:font script="Laoo" typeface="DokChampa"/>
+        <a:font script="Sinh" typeface="Iskoola Pota"/>
+        <a:font script="Mong" typeface="Mongolian Baiti"/>
+        <a:font script="Viet" typeface="Times New Roman"/>
+        <a:font script="Uigh" typeface="Microsoft Uighur"/>
+        <a:font script="Geor" typeface="Sylfaen"/>
+      </a:majorFont>
+      <a:minorFont>
+        <a:latin typeface="Calibri"/>
+        <a:ea typeface=""/>
+        <a:cs typeface=""/>
+        <a:font script="Jpan" typeface="ＭＳ Ｐゴシック"/>
+        <a:font script="Hang" typeface="맑은 고딕"/>
+        <a:font script="Hans" typeface="宋体"/>
+        <a:font script="Hant" typeface="新細明體"/>
+        <a:font script="Arab" typeface="Arial"/>
+        <a:font script="Hebr" typeface="Arial"/>
+        <a:font script="Thai" typeface="Cordia New"/>
+        <a:font script="Ethi" typeface="Nyala"/>
+        <a:font script="Beng" typeface="Vrinda"/>
+        <a:font script="Gujr" typeface="Shruti"/>
+        <a:font script="Khmr" typeface="DaunPenh"/>
+        <a:font script="Knda" typeface="Tunga"/>
+        <a:font script="Guru" typeface="Raavi"/>
+        <a:font script="Cans" typeface="Euphemia"/>
+        <a:font script="Cher" typeface="Plantagenet Cherokee"/>
+        <a:font script="Yiii" typeface="Microsoft Yi Baiti"/>
+        <a:font script="Tibt" typeface="Microsoft Himalaya"/>
+        <a:font script="Thaa" typeface="MV Boli"/>
+        <a:font script="Deva" typeface="Mangal"/>
+        <a:font script="Telu" typeface="Gautami"/>
+        <a:font script="Taml" typeface="Latha"/>
+        <a:font script="Syrc" typeface="Estrangelo Edessa"/>
+        <a:font script="Orya" typeface="Kalinga"/>
+        <a:font script="Mlym" typeface="Kartika"/>
+        <a:font script="Laoo" typeface="DokChampa"/>
+        <a:font script="Sinh" typeface="Iskoola Pota"/>
+        <a:font script="Mong" typeface="Mongolian Baiti"/>
+        <a:font script="Viet" typeface="Arial"/>
+        <a:font script="Uigh" typeface="Microsoft Uighur"/>
+        <a:font script="Geor" typeface="Sylfaen"/>
+      </a:minorFont>
+    </a:fontScheme>
+    <a:fmtScheme name="Office">
+      <a:fillStyleLst>
+        <a:solidFill>
+          <a:schemeClr val="phClr"/>
+        </a:solidFill>
+        <a:gradFill rotWithShape="1">
+          <a:gsLst>
+            <a:gs pos="0">
+              <a:schemeClr val="phClr">
+                <a:tint val="50000"/>
+                <a:satMod val="300000"/>
+              </a:schemeClr>
+            </a:gs>
+            <a:gs pos="35000">
+              <a:schemeClr val="phClr">
+                <a:tint val="37000"/>
+                <a:satMod val="300000"/>
+              </a:schemeClr>
+            </a:gs>
+            <a:gs pos="100000">
+              <a:schemeClr val="phClr">
+                <a:tint val="15000"/>
+                <a:satMod val="350000"/>
+              </a:schemeClr>
+            </a:gs>
+          </a:gsLst>
+          <a:lin ang="16200000" scaled="1"/>
+        </a:gradFill>
+        <a:gradFill rotWithShape="1">
+          <a:gsLst>
+            <a:gs pos="0">
+              <a:schemeClr val="phClr">
+                <a:tint val="100000"/>
+                <a:shade val="100000"/>
+                <a:satMod val="130000"/>
+              </a:schemeClr>
+            </a:gs>
+            <a:gs pos="100000">
+              <a:schemeClr val="phClr">
+                <a:tint val="50000"/>
+                <a:shade val="100000"/>
+                <a:satMod val="350000"/>
+              </a:schemeClr>
+            </a:gs>
+          </a:gsLst>
+          <a:lin ang="16200000" scaled="0"/>
+        </a:gradFill>
+      </a:fillStyleLst>
+      <a:lnStyleLst>
+        <a:ln w="9525" cap="flat" cmpd="sng" algn="ctr">
+          <a:solidFill>
+            <a:schemeClr val="phClr">
+              <a:shade val="95000"/>
+              <a:satMod val="105000"/>
+            </a:schemeClr>
+          </a:solidFill>
+          <a:prstDash val="solid"/>
+        </a:ln>
+        <a:ln w="25400" cap="flat" cmpd="sng" algn="ctr">
+          <a:solidFill>
+            <a:schemeClr val="phClr"/>
+          </a:solidFill>
+          <a:prstDash val="solid"/>
+        </a:ln>
+        <a:ln w="38100" cap="flat" cmpd="sng" algn="ctr">
+          <a:solidFill>
+            <a:schemeClr val="phClr"/>
+          </a:solidFill>
+          <a:prstDash val="solid"/>
+        </a:ln>
+      </a:lnStyleLst>
+      <a:effectStyleLst>
+        <a:effectStyle>
+          <a:effectLst>
+            <a:outerShdw blurRad="40000" dist="20000" dir="5400000" rotWithShape="0">
+              <a:srgbClr val="000000">
+                <a:alpha val="38000"/>
+              </a:srgbClr>
+            </a:outerShdw>
+          </a:effectLst>
+        </a:effectStyle>
+        <a:effectStyle>
+          <a:effectLst>
+            <a:outerShdw blurRad="40000" dist="23000" dir="5400000" rotWithShape="0">
+              <a:srgbClr val="000000">
+                <a:alpha val="35000"/>
+              </a:srgbClr>
+            </a:outerShdw>
+          </a:effectLst>
+        </a:effectStyle>
+        <a:effectStyle>
+          <a:effectLst>
+            <a:outerShdw blurRad="40000" dist="23000" dir="5400000" rotWithShape="0">
+              <a:srgbClr val="000000">
+                <a:alpha val="35000"/>
+              </a:srgbClr>
+            </a:outerShdw>
+          </a:effectLst>
+          <a:scene3d>
+            <a:camera prst="orthographicFront">
+              <a:rot lat="0" lon="0" rev="0"/>
+            </a:camera>
+            <a:lightRig rig="threePt" dir="t">
+              <a:rot lat="0" lon="0" rev="1200000"/>
+            </a:lightRig>
+          </a:scene3d>
+          <a:sp3d>
+            <a:bevelT w="63500" h="25400"/>
+          </a:sp3d>
+        </a:effectStyle>
+      </a:effectStyleLst>
+      <a:bgFillStyleLst>
+        <a:solidFill>
+          <a:schemeClr val="phClr"/>
+        </a:solidFill>
+        <a:gradFill rotWithShape="1">
+          <a:gsLst>
+            <a:gs pos="0">
+              <a:schemeClr val="phClr">
+                <a:tint val="40000"/>
+                <a:satMod val="350000"/>
+              </a:schemeClr>
+            </a:gs>
+            <a:gs pos="40000">
+              <a:schemeClr val="phClr">
+                <a:tint val="45000"/>
+                <a:shade val="99000"/>
+                <a:satMod val="350000"/>
+              </a:schemeClr>
+            </a:gs>
+            <a:gs pos="100000">
+              <a:schemeClr val="phClr">
+                <a:shade val="20000"/>
+                <a:satMod val="255000"/>
+              </a:schemeClr>
+            </a:gs>
+          </a:gsLst>
+          <a:path path="circle">
+            <a:fillToRect l="50000" t="-80000" r="50000" b="180000"/>
+          </a:path>
+        </a:gradFill>
+        <a:gradFill rotWithShape="1">
+          <a:gsLst>
+            <a:gs pos="0">
+              <a:schemeClr val="phClr">
+                <a:tint val="80000"/>
+                <a:satMod val="300000"/>
+              </a:schemeClr>
+            </a:gs>
+            <a:gs pos="100000">
+              <a:schemeClr val="phClr">
+                <a:shade val="30000"/>
+                <a:satMod val="200000"/>
+              </a:schemeClr>
+            </a:gs>
+          </a:gsLst>
+          <a:path path="circle">
+            <a:fillToRect l="50000" t="50000" r="50000" b="50000"/>
+          </a:path>
+        </a:gradFill>
+      </a:bgFillStyleLst>
+    </a:fmtScheme>
+  </a:themeElements>
+  <a:objectDefaults>
+    <a:spDef>
+      <a:spPr/>
+      <a:bodyPr/>
+      <a:lstStyle/>
+      <a:style>
+        <a:lnRef idx="1">
+          <a:schemeClr val="accent1"/>
+        </a:lnRef>
+        <a:fillRef idx="3">
+          <a:schemeClr val="accent1"/>
+        </a:fillRef>
+        <a:effectRef idx="2">
+          <a:schemeClr val="accent1"/>
+        </a:effectRef>
+        <a:fontRef idx="minor">
+          <a:schemeClr val="lt1"/>
+        </a:fontRef>
+      </a:style>
+    </a:spDef>
+    <a:lnDef>
+      <a:spPr/>
+      <a:bodyPr/>
+      <a:lstStyle/>
+      <a:style>
+        <a:lnRef idx="2">
+          <a:schemeClr val="accent1"/>
+        </a:lnRef>
+        <a:fillRef idx="0">
+          <a:schemeClr val="accent1"/>
+        </a:fillRef>
+        <a:effectRef idx="1">
+          <a:schemeClr val="accent1"/>
+        </a:effectRef>
+        <a:fontRef idx="minor">
+          <a:schemeClr val="tx1"/>
+        </a:fontRef>
+      </a:style>
+    </a:lnDef>
+  </a:objectDefaults>
+  <a:extraClrSchemeLst/>
+</a:theme>
 </file>
</xml_diff>